<commit_message>
docs: update Ubuntu node terminology from Ubuntu Server to Ubuntu standard
</commit_message>
<xml_diff>
--- a/docs/SLIDE_BAO_CAO_TIEN_DO.pptx
+++ b/docs/SLIDE_BAO_CAO_TIEN_DO.pptx
@@ -2687,7 +2687,7 @@
                 <a:ea typeface="Calibri" pitchFamily="34" charset="-122"/>
                 <a:cs typeface="Calibri" pitchFamily="34" charset="-120"/>
               </a:rPr>
-              <a:t>Bảng số liệu đo lường trực tiếp giữa Arch Linux (Rootless) và Ubuntu Server (Rootful)</a:t>
+              <a:t>Bảng số liệu đo lường trực tiếp giữa Arch Linux (Rootless) và Ubuntu (Rootful)</a:t>
             </a:r>
             <a:endParaRPr lang="en-US" sz="1250" dirty="0"/>
           </a:p>
@@ -3575,7 +3575,7 @@
                           <a:ea typeface="Calibri" pitchFamily="34" charset="-122"/>
                           <a:cs typeface="Calibri" pitchFamily="34" charset="-120"/>
                         </a:rPr>
-                        <a:t>Ubuntu Server (Rootful Docker)</a:t>
+                        <a:t>Ubuntu (Rootful Docker)</a:t>
                       </a:r>
                       <a:endParaRPr lang="en-US" sz="1050" dirty="0">
                         <a:latin typeface="Calibri" charset="0"/>
@@ -6343,7 +6343,7 @@
                 <a:ea typeface="Calibri" pitchFamily="34" charset="-122"/>
                 <a:cs typeface="Calibri" pitchFamily="34" charset="-120"/>
               </a:rPr>
-              <a:t>Chịu trách nhiệm triển khai nút Ubuntu Server baseline, chuẩn hóa cấu hình đối chứng và kiểm thử an ninh mạng.</a:t>
+              <a:t>Chịu trách nhiệm triển khai nút Ubuntu baseline, chuẩn hóa cấu hình đối chứng và kiểm thử an ninh mạng.</a:t>
             </a:r>
             <a:endParaRPr lang="en-US" sz="1000" dirty="0"/>
           </a:p>
@@ -7860,7 +7860,7 @@
                 <a:ea typeface="Calibri" pitchFamily="34" charset="-122"/>
                 <a:cs typeface="Calibri" pitchFamily="34" charset="-120"/>
               </a:rPr>
-              <a:t>Ubuntu Server: Chu kỳ LTS 5 năm ổn định, phổ biến nhưng cồng kềnh (~750MB RAM), nhiều daemon nền mặc định.</a:t>
+              <a:t>Ubuntu: Chu kỳ LTS 5 năm ổn định, phổ biến nhưng cồng kềnh (~750MB RAM), nhiều daemon nền mặc định.</a:t>
             </a:r>
             <a:endParaRPr lang="en-US" sz="1300" dirty="0"/>
           </a:p>
@@ -9688,7 +9688,7 @@
                 <a:ea typeface="Calibri" pitchFamily="34" charset="-122"/>
                 <a:cs typeface="Calibri" pitchFamily="34" charset="-120"/>
               </a:rPr>
-              <a:t>Mô hình thực nghiệm đối kháng song song giữa nút Arch Linux và nút Ubuntu Server</a:t>
+              <a:t>Mô hình thực nghiệm đối kháng song song giữa nút Arch Linux và nút Ubuntu</a:t>
             </a:r>
             <a:endParaRPr lang="en-US" sz="1250" dirty="0"/>
           </a:p>
@@ -10427,7 +10427,7 @@
                 <a:ea typeface="Calibri" pitchFamily="34" charset="-122"/>
                 <a:cs typeface="Calibri" pitchFamily="34" charset="-120"/>
               </a:rPr>
-              <a:t>Hệ điều hành: Ubuntu Server 22.04 / 24.04 LTS (Nhân Linux 6.8 Enterprise).</a:t>
+              <a:t>Hệ điều hành: Ubuntu 22.04 / 24.04 LTS (Nhân Linux 6.8 Enterprise).</a:t>
             </a:r>
             <a:endParaRPr lang="en-US" sz="1050" dirty="0"/>
           </a:p>

</xml_diff>